<commit_message>
Update Final State for Presentation
</commit_message>
<xml_diff>
--- a/reports/Presentation.pptx
+++ b/reports/Presentation.pptx
@@ -4,12 +4,12 @@
   <p:sldMasterIdLst>
     <p:sldMasterId id="2147483648" r:id="rId1"/>
   </p:sldMasterIdLst>
+  <p:notesMasterIdLst>
+    <p:notesMasterId r:id="rId3"/>
+  </p:notesMasterIdLst>
   <p:sldIdLst>
     <p:sldId id="256" r:id="rId2"/>
   </p:sldIdLst>
-  <p:notesMasterIdLst>
-    <p:notesMasterId r:id="rId3"/>
-  </p:notesMasterIdLst>
   <p:sldSz cx="12192000" cy="6858000"/>
   <p:notesSz cx="6858000" cy="12192000"/>
   <p:defaultTextStyle>
@@ -104,6 +104,11 @@
       </a:defRPr>
     </a:lvl9pPr>
   </p:defaultTextStyle>
+  <p:extLst>
+    <p:ext uri="{EFAFB233-063F-42B5-8137-9DF3F51BA10A}">
+      <p15:sldGuideLst xmlns:p15="http://schemas.microsoft.com/office/powerpoint/2012/main"/>
+    </p:ext>
+  </p:extLst>
 </p:presentation>
 </file>
 
@@ -129,234 +134,10 @@
           <a:chExt cx="0" cy="0"/>
         </a:xfrm>
       </p:grpSpPr>
-      <p:sp>
-        <p:nvSpPr>
-          <p:cNvPr id="2" name="Header Placeholder 1"/>
-          <p:cNvSpPr>
-            <a:spLocks noGrp="1"/>
-          </p:cNvSpPr>
-          <p:nvPr>
-            <p:ph type="hdr" sz="quarter"/>
-          </p:nvPr>
-        </p:nvSpPr>
-        <p:spPr>
-          <a:xfrm>
-            <a:off x="0" y="0"/>
-            <a:ext cx="2971800" cy="458788"/>
-          </a:xfrm>
-          <a:prstGeom prst="rect">
-            <a:avLst/>
-          </a:prstGeom>
-        </p:spPr>
-        <p:txBody>
-          <a:bodyPr vert="horz" lIns="91440" tIns="45720" rIns="91440" bIns="45720" rtlCol="0"/>
-          <a:lstStyle>
-            <a:lvl1pPr algn="l">
-              <a:defRPr sz="1200"/>
-            </a:lvl1pPr>
-          </a:lstStyle>
-          <a:p>
-            <a:endParaRPr lang="en-US"/>
-          </a:p>
-        </p:txBody>
-      </p:sp>
-      <p:sp>
-        <p:nvSpPr>
-          <p:cNvPr id="3" name="Date Placeholder 2"/>
-          <p:cNvSpPr>
-            <a:spLocks noGrp="1"/>
-          </p:cNvSpPr>
-          <p:nvPr>
-            <p:ph type="dt" idx="1"/>
-          </p:nvPr>
-        </p:nvSpPr>
-        <p:spPr>
-          <a:xfrm>
-            <a:off x="3884613" y="0"/>
-            <a:ext cx="2971800" cy="458788"/>
-          </a:xfrm>
-          <a:prstGeom prst="rect">
-            <a:avLst/>
-          </a:prstGeom>
-        </p:spPr>
-        <p:txBody>
-          <a:bodyPr vert="horz" lIns="91440" tIns="45720" rIns="91440" bIns="45720" rtlCol="0"/>
-          <a:lstStyle>
-            <a:lvl1pPr algn="r">
-              <a:defRPr sz="1200"/>
-            </a:lvl1pPr>
-          </a:lstStyle>
-          <a:p>
-            <a:fld id="{5282F153-3F37-0F45-9E97-73ACFA13230C}" type="datetimeFigureOut">
-              <a:rPr lang="en-US"/>
-              <a:t>7/23/19</a:t>
-            </a:fld>
-            <a:endParaRPr lang="en-US"/>
-          </a:p>
-        </p:txBody>
-      </p:sp>
-      <p:sp>
-        <p:nvSpPr>
-          <p:cNvPr id="4" name="Slide Image Placeholder 3"/>
-          <p:cNvSpPr>
-            <a:spLocks noGrp="1" noRot="1" noChangeAspect="1"/>
-          </p:cNvSpPr>
-          <p:nvPr>
-            <p:ph type="sldImg" idx="2"/>
-          </p:nvPr>
-        </p:nvSpPr>
-        <p:spPr>
-          <a:xfrm>
-            <a:off x="685800" y="1143000"/>
-            <a:ext cx="5486400" cy="3086100"/>
-          </a:xfrm>
-          <a:prstGeom prst="rect">
-            <a:avLst/>
-          </a:prstGeom>
-          <a:noFill/>
-          <a:ln w="12700">
-            <a:solidFill>
-              <a:prstClr val="black"/>
-            </a:solidFill>
-          </a:ln>
-        </p:spPr>
-        <p:txBody>
-          <a:bodyPr vert="horz" lIns="91440" tIns="45720" rIns="91440" bIns="45720" rtlCol="0" anchor="ctr"/>
-          <a:lstStyle/>
-          <a:p>
-            <a:endParaRPr lang="en-US"/>
-          </a:p>
-        </p:txBody>
-      </p:sp>
-      <p:sp>
-        <p:nvSpPr>
-          <p:cNvPr id="5" name="Notes Placeholder 4"/>
-          <p:cNvSpPr>
-            <a:spLocks noGrp="1"/>
-          </p:cNvSpPr>
-          <p:nvPr>
-            <p:ph type="body" sz="quarter" idx="3"/>
-          </p:nvPr>
-        </p:nvSpPr>
-        <p:spPr>
-          <a:xfrm>
-            <a:off x="685800" y="4400550"/>
-            <a:ext cx="5486400" cy="3600450"/>
-          </a:xfrm>
-          <a:prstGeom prst="rect">
-            <a:avLst/>
-          </a:prstGeom>
-        </p:spPr>
-        <p:txBody>
-          <a:bodyPr vert="horz" lIns="91440" tIns="45720" rIns="91440" bIns="45720" rtlCol="0"/>
-          <a:lstStyle/>
-          <a:p>
-            <a:pPr lvl="0"/>
-            <a:r>
-              <a:rPr lang="en-US"/>
-              <a:t>Click to edit Master text styles</a:t>
-            </a:r>
-          </a:p>
-          <a:p>
-            <a:pPr lvl="1"/>
-            <a:r>
-              <a:rPr lang="en-US"/>
-              <a:t>Second level</a:t>
-            </a:r>
-          </a:p>
-          <a:p>
-            <a:pPr lvl="2"/>
-            <a:r>
-              <a:rPr lang="en-US"/>
-              <a:t>Third level</a:t>
-            </a:r>
-          </a:p>
-          <a:p>
-            <a:pPr lvl="3"/>
-            <a:r>
-              <a:rPr lang="en-US"/>
-              <a:t>Fourth level</a:t>
-            </a:r>
-          </a:p>
-          <a:p>
-            <a:pPr lvl="4"/>
-            <a:r>
-              <a:rPr lang="en-US"/>
-              <a:t>Fifth level</a:t>
-            </a:r>
-          </a:p>
-        </p:txBody>
-      </p:sp>
-      <p:sp>
-        <p:nvSpPr>
-          <p:cNvPr id="6" name="Footer Placeholder 5"/>
-          <p:cNvSpPr>
-            <a:spLocks noGrp="1"/>
-          </p:cNvSpPr>
-          <p:nvPr>
-            <p:ph type="ftr" sz="quarter" idx="4"/>
-          </p:nvPr>
-        </p:nvSpPr>
-        <p:spPr>
-          <a:xfrm>
-            <a:off x="0" y="8685213"/>
-            <a:ext cx="2971800" cy="458787"/>
-          </a:xfrm>
-          <a:prstGeom prst="rect">
-            <a:avLst/>
-          </a:prstGeom>
-        </p:spPr>
-        <p:txBody>
-          <a:bodyPr vert="horz" lIns="91440" tIns="45720" rIns="91440" bIns="45720" rtlCol="0" anchor="b"/>
-          <a:lstStyle>
-            <a:lvl1pPr algn="l">
-              <a:defRPr sz="1200"/>
-            </a:lvl1pPr>
-          </a:lstStyle>
-          <a:p>
-            <a:endParaRPr lang="en-US"/>
-          </a:p>
-        </p:txBody>
-      </p:sp>
-      <p:sp>
-        <p:nvSpPr>
-          <p:cNvPr id="7" name="Slide Number Placeholder 6"/>
-          <p:cNvSpPr>
-            <a:spLocks noGrp="1"/>
-          </p:cNvSpPr>
-          <p:nvPr>
-            <p:ph type="sldNum" sz="quarter" idx="5"/>
-          </p:nvPr>
-        </p:nvSpPr>
-        <p:spPr>
-          <a:xfrm>
-            <a:off x="3884613" y="8685213"/>
-            <a:ext cx="2971800" cy="458787"/>
-          </a:xfrm>
-          <a:prstGeom prst="rect">
-            <a:avLst/>
-          </a:prstGeom>
-        </p:spPr>
-        <p:txBody>
-          <a:bodyPr vert="horz" lIns="91440" tIns="45720" rIns="91440" bIns="45720" rtlCol="0" anchor="b"/>
-          <a:lstStyle>
-            <a:lvl1pPr algn="r">
-              <a:defRPr sz="1200"/>
-            </a:lvl1pPr>
-          </a:lstStyle>
-          <a:p>
-            <a:fld id="{CE5E9CC1-C706-0F49-92D6-E571CC5EEA8F}" type="slidenum">
-              <a:rPr lang="en-US"/>
-              <a:t>‹#›</a:t>
-            </a:fld>
-            <a:endParaRPr lang="en-US"/>
-          </a:p>
-        </p:txBody>
-      </p:sp>
     </p:spTree>
     <p:extLst>
       <p:ext uri="{BB962C8B-B14F-4D97-AF65-F5344CB8AC3E}">
-        <p14:creationId xmlns:p14="http://schemas.microsoft.com/office/powerpoint/2010/main" val="1024086991"/>
+        <p14:creationId xmlns:p14="http://schemas.microsoft.com/office/powerpoint/2010/main" val="3223422859"/>
       </p:ext>
     </p:extLst>
   </p:cSld>
@@ -500,10 +281,6 @@
           <a:bodyPr/>
           <a:lstStyle/>
           <a:p>
-            <a:r>
-              <a:rPr lang="en-US" dirty="0"/>
-              <a:t/>
-            </a:r>
             <a:endParaRPr lang="en-US" dirty="0"/>
           </a:p>
         </p:txBody>
@@ -577,6 +354,11 @@
 <file path=ppt/slideMasters/slideMaster1.xml><?xml version="1.0" encoding="utf-8"?>
 <p:sldMaster xmlns:a="http://schemas.openxmlformats.org/drawingml/2006/main" xmlns:r="http://schemas.openxmlformats.org/officeDocument/2006/relationships" xmlns:p="http://schemas.openxmlformats.org/presentationml/2006/main">
   <p:cSld>
+    <p:bg>
+      <p:bgRef idx="1001">
+        <a:schemeClr val="bg1"/>
+      </p:bgRef>
+    </p:bg>
     <p:spTree>
       <p:nvGrpSpPr>
         <p:cNvPr id="1" name=""/>
@@ -859,6 +641,7 @@
         <a:solidFill>
           <a:srgbClr val="F8FAFC"/>
         </a:solidFill>
+        <a:effectLst/>
       </p:bgPr>
     </p:bg>
     <p:spTree>
@@ -899,6 +682,13 @@
             <a:prstDash val="solid"/>
           </a:ln>
         </p:spPr>
+        <p:txBody>
+          <a:bodyPr/>
+          <a:lstStyle/>
+          <a:p>
+            <a:endParaRPr lang="es-ES"/>
+          </a:p>
+        </p:txBody>
       </p:sp>
       <p:sp>
         <p:nvSpPr>
@@ -921,7 +711,7 @@
           <a:bodyPr wrap="square" lIns="0" tIns="0" rIns="0" bIns="0" rtlCol="0" anchor="ctr"/>
           <a:lstStyle/>
           <a:p>
-            <a:pPr algn="l" indent="0" marL="0">
+            <a:pPr marL="0" indent="0" algn="l">
               <a:buNone/>
             </a:pPr>
             <a:r>
@@ -933,7 +723,7 @@
                 <a:ea typeface="Calibri" pitchFamily="34" charset="-122"/>
                 <a:cs typeface="Calibri" pitchFamily="34" charset="-120"/>
               </a:rPr>
-              <a:t>Does Graph Geometry Help Forecasting the S&amp;P 100?</a:t>
+              <a:t>Does Graph Geometry Help Forecasting S&amp;P 100 Stocks?</a:t>
             </a:r>
             <a:endParaRPr lang="en-US" sz="2200" dirty="0"/>
           </a:p>
@@ -960,7 +750,7 @@
           <a:bodyPr wrap="square" lIns="0" tIns="0" rIns="0" bIns="0" rtlCol="0" anchor="ctr"/>
           <a:lstStyle/>
           <a:p>
-            <a:pPr algn="l" indent="0" marL="0">
+            <a:pPr marL="0" indent="0" algn="l">
               <a:buNone/>
             </a:pPr>
             <a:r>
@@ -999,7 +789,7 @@
           <a:bodyPr wrap="square" lIns="0" tIns="0" rIns="0" bIns="0" rtlCol="0" anchor="ctr"/>
           <a:lstStyle/>
           <a:p>
-            <a:pPr algn="r" indent="0" marL="0">
+            <a:pPr marL="0" indent="0" algn="r">
               <a:buNone/>
             </a:pPr>
             <a:r>
@@ -1038,11 +828,11 @@
           <a:bodyPr wrap="square" lIns="0" tIns="0" rIns="0" bIns="0" rtlCol="0" anchor="ctr"/>
           <a:lstStyle/>
           <a:p>
-            <a:pPr indent="0" marL="0">
+            <a:pPr marL="0" indent="0">
               <a:buNone/>
             </a:pPr>
             <a:r>
-              <a:rPr lang="en-US" sz="800" b="1" spc="300" kern="0" dirty="0">
+              <a:rPr lang="en-US" sz="800" b="1" kern="0" spc="300" dirty="0">
                 <a:solidFill>
                   <a:srgbClr val="2563EB"/>
                 </a:solidFill>
@@ -1080,13 +870,20 @@
             <a:prstDash val="solid"/>
           </a:ln>
           <a:effectLst>
-            <a:outerShdw sx="100000" sy="100000" kx="0" ky="0" algn="bl" rotWithShape="0" blurRad="50800" dist="12700" dir="8100000">
+            <a:outerShdw blurRad="50800" dist="12700" dir="8100000" algn="bl" rotWithShape="0">
               <a:srgbClr val="000000">
                 <a:alpha val="6000"/>
               </a:srgbClr>
             </a:outerShdw>
           </a:effectLst>
         </p:spPr>
+        <p:txBody>
+          <a:bodyPr/>
+          <a:lstStyle/>
+          <a:p>
+            <a:endParaRPr lang="es-ES"/>
+          </a:p>
+        </p:txBody>
       </p:sp>
       <p:sp>
         <p:nvSpPr>
@@ -1112,17 +909,24 @@
             <a:prstDash val="solid"/>
           </a:ln>
         </p:spPr>
+        <p:txBody>
+          <a:bodyPr/>
+          <a:lstStyle/>
+          <a:p>
+            <a:endParaRPr lang="es-ES"/>
+          </a:p>
+        </p:txBody>
       </p:sp>
       <p:pic>
         <p:nvPicPr>
-          <p:cNvPr id="9" name="Image 0" descr="preencoded.png">    </p:cNvPr>
+          <p:cNvPr id="9" name="Image 0" descr="preencoded.png"/>
           <p:cNvPicPr>
             <a:picLocks noChangeAspect="1"/>
           </p:cNvPicPr>
           <p:nvPr/>
         </p:nvPicPr>
         <p:blipFill>
-          <a:blip r:embed="rId1"/>
+          <a:blip r:embed="rId3"/>
           <a:stretch>
             <a:fillRect/>
           </a:stretch>
@@ -1158,7 +962,7 @@
           <a:bodyPr wrap="square" lIns="0" tIns="0" rIns="0" bIns="0" rtlCol="0" anchor="ctr"/>
           <a:lstStyle/>
           <a:p>
-            <a:pPr indent="0" marL="0">
+            <a:pPr marL="0" indent="0">
               <a:buNone/>
             </a:pPr>
             <a:r>
@@ -1197,7 +1001,7 @@
           <a:bodyPr wrap="square" lIns="0" tIns="0" rIns="0" bIns="0" rtlCol="0" anchor="ctr"/>
           <a:lstStyle/>
           <a:p>
-            <a:pPr indent="0" marL="0">
+            <a:pPr marL="0" indent="0">
               <a:buNone/>
             </a:pPr>
             <a:r>
@@ -1209,7 +1013,7 @@
                 <a:ea typeface="Calibri" pitchFamily="34" charset="-122"/>
                 <a:cs typeface="Calibri" pitchFamily="34" charset="-120"/>
               </a:rPr>
-              <a:t>OHLCV, 2018–2024</a:t>
+              <a:t>OHLCV, 2021-2025</a:t>
             </a:r>
             <a:endParaRPr lang="en-US" sz="900" dirty="0"/>
           </a:p>
@@ -1217,14 +1021,14 @@
       </p:sp>
       <p:pic>
         <p:nvPicPr>
-          <p:cNvPr id="12" name="Image 1" descr="preencoded.png">    </p:cNvPr>
+          <p:cNvPr id="12" name="Image 1" descr="preencoded.png"/>
           <p:cNvPicPr>
             <a:picLocks noChangeAspect="1"/>
           </p:cNvPicPr>
           <p:nvPr/>
         </p:nvPicPr>
         <p:blipFill>
-          <a:blip r:embed="rId2"/>
+          <a:blip r:embed="rId4"/>
           <a:stretch>
             <a:fillRect/>
           </a:stretch>
@@ -1263,13 +1067,20 @@
             <a:prstDash val="solid"/>
           </a:ln>
           <a:effectLst>
-            <a:outerShdw sx="100000" sy="100000" kx="0" ky="0" algn="bl" rotWithShape="0" blurRad="50800" dist="12700" dir="8100000">
+            <a:outerShdw blurRad="50800" dist="12700" dir="8100000" algn="bl" rotWithShape="0">
               <a:srgbClr val="000000">
                 <a:alpha val="6000"/>
               </a:srgbClr>
             </a:outerShdw>
           </a:effectLst>
         </p:spPr>
+        <p:txBody>
+          <a:bodyPr/>
+          <a:lstStyle/>
+          <a:p>
+            <a:endParaRPr lang="es-ES"/>
+          </a:p>
+        </p:txBody>
       </p:sp>
       <p:sp>
         <p:nvSpPr>
@@ -1295,17 +1106,24 @@
             <a:prstDash val="solid"/>
           </a:ln>
         </p:spPr>
+        <p:txBody>
+          <a:bodyPr/>
+          <a:lstStyle/>
+          <a:p>
+            <a:endParaRPr lang="es-ES"/>
+          </a:p>
+        </p:txBody>
       </p:sp>
       <p:pic>
         <p:nvPicPr>
-          <p:cNvPr id="15" name="Image 2" descr="preencoded.png">    </p:cNvPr>
+          <p:cNvPr id="15" name="Image 2" descr="preencoded.png"/>
           <p:cNvPicPr>
             <a:picLocks noChangeAspect="1"/>
           </p:cNvPicPr>
           <p:nvPr/>
         </p:nvPicPr>
         <p:blipFill>
-          <a:blip r:embed="rId3"/>
+          <a:blip r:embed="rId5"/>
           <a:stretch>
             <a:fillRect/>
           </a:stretch>
@@ -1341,7 +1159,7 @@
           <a:bodyPr wrap="square" lIns="0" tIns="0" rIns="0" bIns="0" rtlCol="0" anchor="ctr"/>
           <a:lstStyle/>
           <a:p>
-            <a:pPr indent="0" marL="0">
+            <a:pPr marL="0" indent="0">
               <a:buNone/>
             </a:pPr>
             <a:r>
@@ -1380,7 +1198,7 @@
           <a:bodyPr wrap="square" lIns="0" tIns="0" rIns="0" bIns="0" rtlCol="0" anchor="ctr"/>
           <a:lstStyle/>
           <a:p>
-            <a:pPr indent="0" marL="0">
+            <a:pPr marL="0" indent="0">
               <a:buNone/>
             </a:pPr>
             <a:r>
@@ -1400,7 +1218,7 @@
       </p:sp>
       <p:pic>
         <p:nvPicPr>
-          <p:cNvPr id="18" name="Image 3" descr="preencoded.png">    </p:cNvPr>
+          <p:cNvPr id="18" name="Image 3" descr="preencoded.png"/>
           <p:cNvPicPr>
             <a:picLocks noChangeAspect="1"/>
           </p:cNvPicPr>
@@ -1446,13 +1264,20 @@
             <a:prstDash val="solid"/>
           </a:ln>
           <a:effectLst>
-            <a:outerShdw sx="100000" sy="100000" kx="0" ky="0" algn="bl" rotWithShape="0" blurRad="50800" dist="12700" dir="8100000">
+            <a:outerShdw blurRad="50800" dist="12700" dir="8100000" algn="bl" rotWithShape="0">
               <a:srgbClr val="000000">
                 <a:alpha val="6000"/>
               </a:srgbClr>
             </a:outerShdw>
           </a:effectLst>
         </p:spPr>
+        <p:txBody>
+          <a:bodyPr/>
+          <a:lstStyle/>
+          <a:p>
+            <a:endParaRPr lang="es-ES"/>
+          </a:p>
+        </p:txBody>
       </p:sp>
       <p:sp>
         <p:nvSpPr>
@@ -1478,201 +1303,17 @@
             <a:prstDash val="solid"/>
           </a:ln>
         </p:spPr>
+        <p:txBody>
+          <a:bodyPr/>
+          <a:lstStyle/>
+          <a:p>
+            <a:endParaRPr lang="es-ES"/>
+          </a:p>
+        </p:txBody>
       </p:sp>
       <p:pic>
         <p:nvPicPr>
-          <p:cNvPr id="21" name="Image 4" descr="preencoded.png">    </p:cNvPr>
-          <p:cNvPicPr>
-            <a:picLocks noChangeAspect="1"/>
-          </p:cNvPicPr>
-          <p:nvPr/>
-        </p:nvPicPr>
-        <p:blipFill>
-          <a:blip r:embed="rId5"/>
-          <a:stretch>
-            <a:fillRect/>
-          </a:stretch>
-        </p:blipFill>
-        <p:spPr>
-          <a:xfrm>
-            <a:off x="384048" y="3081528"/>
-            <a:ext cx="274320" cy="274320"/>
-          </a:xfrm>
-          <a:prstGeom prst="rect">
-            <a:avLst/>
-          </a:prstGeom>
-        </p:spPr>
-      </p:pic>
-      <p:sp>
-        <p:nvSpPr>
-          <p:cNvPr id="22" name="Text 15"/>
-          <p:cNvSpPr/>
-          <p:nvPr/>
-        </p:nvSpPr>
-        <p:spPr>
-          <a:xfrm>
-            <a:off x="731520" y="3054096"/>
-            <a:ext cx="2377440" cy="228600"/>
-          </a:xfrm>
-          <a:prstGeom prst="rect">
-            <a:avLst/>
-          </a:prstGeom>
-          <a:noFill/>
-          <a:ln/>
-        </p:spPr>
-        <p:txBody>
-          <a:bodyPr wrap="square" lIns="0" tIns="0" rIns="0" bIns="0" rtlCol="0" anchor="ctr"/>
-          <a:lstStyle/>
-          <a:p>
-            <a:pPr indent="0" marL="0">
-              <a:buNone/>
-            </a:pPr>
-            <a:r>
-              <a:rPr lang="en-US" sz="1100" b="1" dirty="0">
-                <a:solidFill>
-                  <a:srgbClr val="1E293B"/>
-                </a:solidFill>
-                <a:latin typeface="Calibri" pitchFamily="34" charset="0"/>
-                <a:ea typeface="Calibri" pitchFamily="34" charset="-122"/>
-                <a:cs typeface="Calibri" pitchFamily="34" charset="-120"/>
-              </a:rPr>
-              <a:t>Models</a:t>
-            </a:r>
-            <a:endParaRPr lang="en-US" sz="1100" dirty="0"/>
-          </a:p>
-        </p:txBody>
-      </p:sp>
-      <p:sp>
-        <p:nvSpPr>
-          <p:cNvPr id="23" name="Text 16"/>
-          <p:cNvSpPr/>
-          <p:nvPr/>
-        </p:nvSpPr>
-        <p:spPr>
-          <a:xfrm>
-            <a:off x="731520" y="3273552"/>
-            <a:ext cx="2377440" cy="201168"/>
-          </a:xfrm>
-          <a:prstGeom prst="rect">
-            <a:avLst/>
-          </a:prstGeom>
-          <a:noFill/>
-          <a:ln/>
-        </p:spPr>
-        <p:txBody>
-          <a:bodyPr wrap="square" lIns="0" tIns="0" rIns="0" bIns="0" rtlCol="0" anchor="ctr"/>
-          <a:lstStyle/>
-          <a:p>
-            <a:pPr indent="0" marL="0">
-              <a:buNone/>
-            </a:pPr>
-            <a:r>
-              <a:rPr lang="en-US" sz="900" i="1" dirty="0">
-                <a:solidFill>
-                  <a:srgbClr val="64748B"/>
-                </a:solidFill>
-                <a:latin typeface="Calibri" pitchFamily="34" charset="0"/>
-                <a:ea typeface="Calibri" pitchFamily="34" charset="-122"/>
-                <a:cs typeface="Calibri" pitchFamily="34" charset="-120"/>
-              </a:rPr>
-              <a:t>4 approaches compared</a:t>
-            </a:r>
-            <a:endParaRPr lang="en-US" sz="900" dirty="0"/>
-          </a:p>
-        </p:txBody>
-      </p:sp>
-      <p:sp>
-        <p:nvSpPr>
-          <p:cNvPr id="24" name="Text 17"/>
-          <p:cNvSpPr/>
-          <p:nvPr/>
-        </p:nvSpPr>
-        <p:spPr>
-          <a:xfrm>
-            <a:off x="228600" y="3657600"/>
-            <a:ext cx="3017520" cy="228600"/>
-          </a:xfrm>
-          <a:prstGeom prst="rect">
-            <a:avLst/>
-          </a:prstGeom>
-          <a:noFill/>
-          <a:ln/>
-        </p:spPr>
-        <p:txBody>
-          <a:bodyPr wrap="square" lIns="0" tIns="0" rIns="0" bIns="0" rtlCol="0" anchor="ctr"/>
-          <a:lstStyle/>
-          <a:p>
-            <a:pPr indent="0" marL="0">
-              <a:buNone/>
-            </a:pPr>
-            <a:r>
-              <a:rPr lang="en-US" sz="950" b="1" dirty="0">
-                <a:solidFill>
-                  <a:srgbClr val="1E293B"/>
-                </a:solidFill>
-                <a:latin typeface="Calibri" pitchFamily="34" charset="0"/>
-                <a:ea typeface="Calibri" pitchFamily="34" charset="-122"/>
-                <a:cs typeface="Calibri" pitchFamily="34" charset="-120"/>
-              </a:rPr>
-              <a:t>Graph Neural Network variants:</a:t>
-            </a:r>
-            <a:endParaRPr lang="en-US" sz="950" dirty="0"/>
-          </a:p>
-        </p:txBody>
-      </p:sp>
-      <p:sp>
-        <p:nvSpPr>
-          <p:cNvPr id="25" name="Shape 18"/>
-          <p:cNvSpPr/>
-          <p:nvPr/>
-        </p:nvSpPr>
-        <p:spPr>
-          <a:xfrm>
-            <a:off x="228600" y="3904488"/>
-            <a:ext cx="3017520" cy="457200"/>
-          </a:xfrm>
-          <a:prstGeom prst="rect">
-            <a:avLst/>
-          </a:prstGeom>
-          <a:solidFill>
-            <a:srgbClr val="F0F9FF"/>
-          </a:solidFill>
-          <a:ln w="9525">
-            <a:solidFill>
-              <a:srgbClr val="BAE6FD"/>
-            </a:solidFill>
-            <a:prstDash val="solid"/>
-          </a:ln>
-        </p:spPr>
-      </p:sp>
-      <p:sp>
-        <p:nvSpPr>
-          <p:cNvPr id="26" name="Shape 19"/>
-          <p:cNvSpPr/>
-          <p:nvPr/>
-        </p:nvSpPr>
-        <p:spPr>
-          <a:xfrm>
-            <a:off x="228600" y="3904488"/>
-            <a:ext cx="64008" cy="457200"/>
-          </a:xfrm>
-          <a:prstGeom prst="rect">
-            <a:avLst/>
-          </a:prstGeom>
-          <a:solidFill>
-            <a:srgbClr val="0EA5E9"/>
-          </a:solidFill>
-          <a:ln w="12700">
-            <a:solidFill>
-              <a:srgbClr val="0EA5E9"/>
-            </a:solidFill>
-            <a:prstDash val="solid"/>
-          </a:ln>
-        </p:spPr>
-      </p:sp>
-      <p:pic>
-        <p:nvPicPr>
-          <p:cNvPr id="27" name="Image 5" descr="preencoded.png">    </p:cNvPr>
+          <p:cNvPr id="21" name="Image 4" descr="preencoded.png"/>
           <p:cNvPicPr>
             <a:picLocks noChangeAspect="1"/>
           </p:cNvPicPr>
@@ -1686,8 +1327,8 @@
         </p:blipFill>
         <p:spPr>
           <a:xfrm>
-            <a:off x="384048" y="3995928"/>
-            <a:ext cx="228600" cy="228600"/>
+            <a:off x="384048" y="3081528"/>
+            <a:ext cx="274320" cy="274320"/>
           </a:xfrm>
           <a:prstGeom prst="rect">
             <a:avLst/>
@@ -1696,14 +1337,14 @@
       </p:pic>
       <p:sp>
         <p:nvSpPr>
-          <p:cNvPr id="28" name="Text 20"/>
-          <p:cNvSpPr/>
-          <p:nvPr/>
-        </p:nvSpPr>
-        <p:spPr>
-          <a:xfrm>
-            <a:off x="731520" y="3941064"/>
-            <a:ext cx="2468880" cy="201168"/>
+          <p:cNvPr id="22" name="Text 15"/>
+          <p:cNvSpPr/>
+          <p:nvPr/>
+        </p:nvSpPr>
+        <p:spPr>
+          <a:xfrm>
+            <a:off x="731520" y="3054096"/>
+            <a:ext cx="2377440" cy="228600"/>
           </a:xfrm>
           <a:prstGeom prst="rect">
             <a:avLst/>
@@ -1715,11 +1356,11 @@
           <a:bodyPr wrap="square" lIns="0" tIns="0" rIns="0" bIns="0" rtlCol="0" anchor="ctr"/>
           <a:lstStyle/>
           <a:p>
-            <a:pPr indent="0" marL="0">
+            <a:pPr marL="0" indent="0">
               <a:buNone/>
             </a:pPr>
             <a:r>
-              <a:rPr lang="en-US" sz="1000" b="1" dirty="0">
+              <a:rPr lang="en-US" sz="1100" b="1" dirty="0">
                 <a:solidFill>
                   <a:srgbClr val="1E293B"/>
                 </a:solidFill>
@@ -1727,22 +1368,22 @@
                 <a:ea typeface="Calibri" pitchFamily="34" charset="-122"/>
                 <a:cs typeface="Calibri" pitchFamily="34" charset="-120"/>
               </a:rPr>
-              <a:t>Corr-GNN</a:t>
-            </a:r>
-            <a:endParaRPr lang="en-US" sz="1000" dirty="0"/>
-          </a:p>
-        </p:txBody>
-      </p:sp>
-      <p:sp>
-        <p:nvSpPr>
-          <p:cNvPr id="29" name="Text 21"/>
-          <p:cNvSpPr/>
-          <p:nvPr/>
-        </p:nvSpPr>
-        <p:spPr>
-          <a:xfrm>
-            <a:off x="731520" y="4133088"/>
-            <a:ext cx="2468880" cy="182880"/>
+              <a:t>Models</a:t>
+            </a:r>
+            <a:endParaRPr lang="en-US" sz="1100" dirty="0"/>
+          </a:p>
+        </p:txBody>
+      </p:sp>
+      <p:sp>
+        <p:nvSpPr>
+          <p:cNvPr id="23" name="Text 16"/>
+          <p:cNvSpPr/>
+          <p:nvPr/>
+        </p:nvSpPr>
+        <p:spPr>
+          <a:xfrm>
+            <a:off x="731520" y="3273552"/>
+            <a:ext cx="2377440" cy="201168"/>
           </a:xfrm>
           <a:prstGeom prst="rect">
             <a:avLst/>
@@ -1754,11 +1395,11 @@
           <a:bodyPr wrap="square" lIns="0" tIns="0" rIns="0" bIns="0" rtlCol="0" anchor="ctr"/>
           <a:lstStyle/>
           <a:p>
-            <a:pPr indent="0" marL="0">
+            <a:pPr marL="0" indent="0">
               <a:buNone/>
             </a:pPr>
             <a:r>
-              <a:rPr lang="en-US" sz="850" i="1" dirty="0">
+              <a:rPr lang="en-US" sz="900" i="1" dirty="0">
                 <a:solidFill>
                   <a:srgbClr val="64748B"/>
                 </a:solidFill>
@@ -1766,21 +1407,60 @@
                 <a:ea typeface="Calibri" pitchFamily="34" charset="-122"/>
                 <a:cs typeface="Calibri" pitchFamily="34" charset="-120"/>
               </a:rPr>
-              <a:t>Top-5 Pearson return neighbors</a:t>
-            </a:r>
-            <a:endParaRPr lang="en-US" sz="850" dirty="0"/>
-          </a:p>
-        </p:txBody>
-      </p:sp>
-      <p:sp>
-        <p:nvSpPr>
-          <p:cNvPr id="30" name="Shape 22"/>
-          <p:cNvSpPr/>
-          <p:nvPr/>
-        </p:nvSpPr>
-        <p:spPr>
-          <a:xfrm>
-            <a:off x="228600" y="4407408"/>
+              <a:t>RF · LSTM · Corr-GNN · JS-GNN</a:t>
+            </a:r>
+            <a:endParaRPr lang="en-US" sz="900" dirty="0"/>
+          </a:p>
+        </p:txBody>
+      </p:sp>
+      <p:sp>
+        <p:nvSpPr>
+          <p:cNvPr id="24" name="Text 17"/>
+          <p:cNvSpPr/>
+          <p:nvPr/>
+        </p:nvSpPr>
+        <p:spPr>
+          <a:xfrm>
+            <a:off x="228600" y="3657600"/>
+            <a:ext cx="3017520" cy="228600"/>
+          </a:xfrm>
+          <a:prstGeom prst="rect">
+            <a:avLst/>
+          </a:prstGeom>
+          <a:noFill/>
+          <a:ln/>
+        </p:spPr>
+        <p:txBody>
+          <a:bodyPr wrap="square" lIns="0" tIns="0" rIns="0" bIns="0" rtlCol="0" anchor="ctr"/>
+          <a:lstStyle/>
+          <a:p>
+            <a:pPr marL="0" indent="0">
+              <a:buNone/>
+            </a:pPr>
+            <a:r>
+              <a:rPr lang="en-US" sz="950" b="1" dirty="0">
+                <a:solidFill>
+                  <a:srgbClr val="1E293B"/>
+                </a:solidFill>
+                <a:latin typeface="Calibri" pitchFamily="34" charset="0"/>
+                <a:ea typeface="Calibri" pitchFamily="34" charset="-122"/>
+                <a:cs typeface="Calibri" pitchFamily="34" charset="-120"/>
+              </a:rPr>
+              <a:t>Graph Neural Network variants:</a:t>
+            </a:r>
+            <a:endParaRPr lang="en-US" sz="950" dirty="0"/>
+          </a:p>
+        </p:txBody>
+      </p:sp>
+      <p:sp>
+        <p:nvSpPr>
+          <p:cNvPr id="25" name="Shape 18"/>
+          <p:cNvSpPr/>
+          <p:nvPr/>
+        </p:nvSpPr>
+        <p:spPr>
+          <a:xfrm>
+            <a:off x="228600" y="3904488"/>
             <a:ext cx="3017520" cy="457200"/>
           </a:xfrm>
           <a:prstGeom prst="rect">
@@ -1796,35 +1476,49 @@
             <a:prstDash val="solid"/>
           </a:ln>
         </p:spPr>
-      </p:sp>
-      <p:sp>
-        <p:nvSpPr>
-          <p:cNvPr id="31" name="Shape 23"/>
-          <p:cNvSpPr/>
-          <p:nvPr/>
-        </p:nvSpPr>
-        <p:spPr>
-          <a:xfrm>
-            <a:off x="228600" y="4407408"/>
+        <p:txBody>
+          <a:bodyPr/>
+          <a:lstStyle/>
+          <a:p>
+            <a:endParaRPr lang="es-ES"/>
+          </a:p>
+        </p:txBody>
+      </p:sp>
+      <p:sp>
+        <p:nvSpPr>
+          <p:cNvPr id="26" name="Shape 19"/>
+          <p:cNvSpPr/>
+          <p:nvPr/>
+        </p:nvSpPr>
+        <p:spPr>
+          <a:xfrm>
+            <a:off x="228600" y="3904488"/>
             <a:ext cx="64008" cy="457200"/>
           </a:xfrm>
           <a:prstGeom prst="rect">
             <a:avLst/>
           </a:prstGeom>
           <a:solidFill>
-            <a:srgbClr val="8B5CF6"/>
+            <a:srgbClr val="0EA5E9"/>
           </a:solidFill>
           <a:ln w="12700">
             <a:solidFill>
-              <a:srgbClr val="8B5CF6"/>
+              <a:srgbClr val="0EA5E9"/>
             </a:solidFill>
             <a:prstDash val="solid"/>
           </a:ln>
         </p:spPr>
+        <p:txBody>
+          <a:bodyPr/>
+          <a:lstStyle/>
+          <a:p>
+            <a:endParaRPr lang="es-ES"/>
+          </a:p>
+        </p:txBody>
       </p:sp>
       <p:pic>
         <p:nvPicPr>
-          <p:cNvPr id="32" name="Image 6" descr="preencoded.png">    </p:cNvPr>
+          <p:cNvPr id="27" name="Image 5" descr="preencoded.png"/>
           <p:cNvPicPr>
             <a:picLocks noChangeAspect="1"/>
           </p:cNvPicPr>
@@ -1838,7 +1532,7 @@
         </p:blipFill>
         <p:spPr>
           <a:xfrm>
-            <a:off x="384048" y="4498848"/>
+            <a:off x="384048" y="3995928"/>
             <a:ext cx="228600" cy="228600"/>
           </a:xfrm>
           <a:prstGeom prst="rect">
@@ -1848,13 +1542,13 @@
       </p:pic>
       <p:sp>
         <p:nvSpPr>
-          <p:cNvPr id="33" name="Text 24"/>
-          <p:cNvSpPr/>
-          <p:nvPr/>
-        </p:nvSpPr>
-        <p:spPr>
-          <a:xfrm>
-            <a:off x="731520" y="4443984"/>
+          <p:cNvPr id="28" name="Text 20"/>
+          <p:cNvSpPr/>
+          <p:nvPr/>
+        </p:nvSpPr>
+        <p:spPr>
+          <a:xfrm>
+            <a:off x="731520" y="3941064"/>
             <a:ext cx="2468880" cy="201168"/>
           </a:xfrm>
           <a:prstGeom prst="rect">
@@ -1867,7 +1561,7 @@
           <a:bodyPr wrap="square" lIns="0" tIns="0" rIns="0" bIns="0" rtlCol="0" anchor="ctr"/>
           <a:lstStyle/>
           <a:p>
-            <a:pPr indent="0" marL="0">
+            <a:pPr marL="0" indent="0">
               <a:buNone/>
             </a:pPr>
             <a:r>
@@ -1879,7 +1573,7 @@
                 <a:ea typeface="Calibri" pitchFamily="34" charset="-122"/>
                 <a:cs typeface="Calibri" pitchFamily="34" charset="-120"/>
               </a:rPr>
-              <a:t>JS-GNN</a:t>
+              <a:t>Corr-GNN</a:t>
             </a:r>
             <a:endParaRPr lang="en-US" sz="1000" dirty="0"/>
           </a:p>
@@ -1887,13 +1581,13 @@
       </p:sp>
       <p:sp>
         <p:nvSpPr>
-          <p:cNvPr id="34" name="Text 25"/>
-          <p:cNvSpPr/>
-          <p:nvPr/>
-        </p:nvSpPr>
-        <p:spPr>
-          <a:xfrm>
-            <a:off x="731520" y="4636008"/>
+          <p:cNvPr id="29" name="Text 21"/>
+          <p:cNvSpPr/>
+          <p:nvPr/>
+        </p:nvSpPr>
+        <p:spPr>
+          <a:xfrm>
+            <a:off x="731520" y="4133088"/>
             <a:ext cx="2468880" cy="182880"/>
           </a:xfrm>
           <a:prstGeom prst="rect">
@@ -1906,7 +1600,7 @@
           <a:bodyPr wrap="square" lIns="0" tIns="0" rIns="0" bIns="0" rtlCol="0" anchor="ctr"/>
           <a:lstStyle/>
           <a:p>
-            <a:pPr indent="0" marL="0">
+            <a:pPr marL="0" indent="0">
               <a:buNone/>
             </a:pPr>
             <a:r>
@@ -1918,7 +1612,7 @@
                 <a:ea typeface="Calibri" pitchFamily="34" charset="-122"/>
                 <a:cs typeface="Calibri" pitchFamily="34" charset="-120"/>
               </a:rPr>
-              <a:t>Top-5 Jensen-Shannon neighbors</a:t>
+              <a:t>Top-5 Pearson return neighbors</a:t>
             </a:r>
             <a:endParaRPr lang="en-US" sz="850" dirty="0"/>
           </a:p>
@@ -1926,85 +1620,71 @@
       </p:sp>
       <p:sp>
         <p:nvSpPr>
-          <p:cNvPr id="35" name="Text 26"/>
-          <p:cNvSpPr/>
-          <p:nvPr/>
-        </p:nvSpPr>
-        <p:spPr>
-          <a:xfrm>
-            <a:off x="301752" y="4956048"/>
-            <a:ext cx="2926080" cy="201168"/>
-          </a:xfrm>
-          <a:prstGeom prst="rect">
-            <a:avLst/>
-          </a:prstGeom>
-          <a:noFill/>
-          <a:ln/>
-        </p:spPr>
-        <p:txBody>
-          <a:bodyPr wrap="square" lIns="0" tIns="0" rIns="0" bIns="0" rtlCol="0" anchor="ctr"/>
-          <a:lstStyle/>
-          <a:p>
-            <a:pPr indent="0" marL="0">
-              <a:buNone/>
-            </a:pPr>
-            <a:r>
-              <a:rPr lang="en-US" sz="850" i="1" dirty="0">
-                <a:solidFill>
-                  <a:srgbClr val="64748B"/>
-                </a:solidFill>
-                <a:latin typeface="Calibri" pitchFamily="34" charset="0"/>
-                <a:ea typeface="Calibri" pitchFamily="34" charset="-122"/>
-                <a:cs typeface="Calibri" pitchFamily="34" charset="-120"/>
-              </a:rPr>
-              <a:t>+ Sector edges on all graph variants</a:t>
-            </a:r>
-            <a:endParaRPr lang="en-US" sz="850" dirty="0"/>
-          </a:p>
-        </p:txBody>
-      </p:sp>
-      <p:sp>
-        <p:nvSpPr>
-          <p:cNvPr id="36" name="Text 27"/>
-          <p:cNvSpPr/>
-          <p:nvPr/>
-        </p:nvSpPr>
-        <p:spPr>
-          <a:xfrm>
-            <a:off x="3474720" y="1143000"/>
-            <a:ext cx="5760720" cy="256032"/>
-          </a:xfrm>
-          <a:prstGeom prst="rect">
-            <a:avLst/>
-          </a:prstGeom>
-          <a:noFill/>
-          <a:ln/>
-        </p:spPr>
-        <p:txBody>
-          <a:bodyPr wrap="square" lIns="0" tIns="0" rIns="0" bIns="0" rtlCol="0" anchor="ctr"/>
-          <a:lstStyle/>
-          <a:p>
-            <a:pPr indent="0" marL="0">
-              <a:buNone/>
-            </a:pPr>
-            <a:r>
-              <a:rPr lang="en-US" sz="800" b="1" spc="300" kern="0" dirty="0">
-                <a:solidFill>
-                  <a:srgbClr val="2563EB"/>
-                </a:solidFill>
-                <a:latin typeface="Calibri" pitchFamily="34" charset="0"/>
-                <a:ea typeface="Calibri" pitchFamily="34" charset="-122"/>
-                <a:cs typeface="Calibri" pitchFamily="34" charset="-120"/>
-              </a:rPr>
-              <a:t>RESULTS</a:t>
-            </a:r>
-            <a:endParaRPr lang="en-US" sz="800" dirty="0"/>
+          <p:cNvPr id="30" name="Shape 22"/>
+          <p:cNvSpPr/>
+          <p:nvPr/>
+        </p:nvSpPr>
+        <p:spPr>
+          <a:xfrm>
+            <a:off x="228600" y="4407408"/>
+            <a:ext cx="3017520" cy="457200"/>
+          </a:xfrm>
+          <a:prstGeom prst="rect">
+            <a:avLst/>
+          </a:prstGeom>
+          <a:solidFill>
+            <a:srgbClr val="F0F9FF"/>
+          </a:solidFill>
+          <a:ln w="9525">
+            <a:solidFill>
+              <a:srgbClr val="BAE6FD"/>
+            </a:solidFill>
+            <a:prstDash val="solid"/>
+          </a:ln>
+        </p:spPr>
+        <p:txBody>
+          <a:bodyPr/>
+          <a:lstStyle/>
+          <a:p>
+            <a:endParaRPr lang="es-ES"/>
+          </a:p>
+        </p:txBody>
+      </p:sp>
+      <p:sp>
+        <p:nvSpPr>
+          <p:cNvPr id="31" name="Shape 23"/>
+          <p:cNvSpPr/>
+          <p:nvPr/>
+        </p:nvSpPr>
+        <p:spPr>
+          <a:xfrm>
+            <a:off x="228600" y="4407408"/>
+            <a:ext cx="64008" cy="457200"/>
+          </a:xfrm>
+          <a:prstGeom prst="rect">
+            <a:avLst/>
+          </a:prstGeom>
+          <a:solidFill>
+            <a:srgbClr val="8B5CF6"/>
+          </a:solidFill>
+          <a:ln w="12700">
+            <a:solidFill>
+              <a:srgbClr val="8B5CF6"/>
+            </a:solidFill>
+            <a:prstDash val="solid"/>
+          </a:ln>
+        </p:spPr>
+        <p:txBody>
+          <a:bodyPr/>
+          <a:lstStyle/>
+          <a:p>
+            <a:endParaRPr lang="es-ES"/>
           </a:p>
         </p:txBody>
       </p:sp>
       <p:pic>
         <p:nvPicPr>
-          <p:cNvPr id="37" name="Image 7" descr="/home/claude/model_comparison_row.png">    </p:cNvPr>
+          <p:cNvPr id="32" name="Image 6" descr="preencoded.png"/>
           <p:cNvPicPr>
             <a:picLocks noChangeAspect="1"/>
           </p:cNvPicPr>
@@ -2018,8 +1698,8 @@
         </p:blipFill>
         <p:spPr>
           <a:xfrm>
-            <a:off x="3474720" y="1417320"/>
-            <a:ext cx="5669280" cy="2182724"/>
+            <a:off x="384048" y="4498848"/>
+            <a:ext cx="228600" cy="228600"/>
           </a:xfrm>
           <a:prstGeom prst="rect">
             <a:avLst/>
@@ -2028,14 +1708,14 @@
       </p:pic>
       <p:sp>
         <p:nvSpPr>
-          <p:cNvPr id="38" name="Text 28"/>
-          <p:cNvSpPr/>
-          <p:nvPr/>
-        </p:nvSpPr>
-        <p:spPr>
-          <a:xfrm>
-            <a:off x="3474720" y="3645764"/>
-            <a:ext cx="5669280" cy="201168"/>
+          <p:cNvPr id="33" name="Text 24"/>
+          <p:cNvSpPr/>
+          <p:nvPr/>
+        </p:nvSpPr>
+        <p:spPr>
+          <a:xfrm>
+            <a:off x="731520" y="4443984"/>
+            <a:ext cx="2468880" cy="201168"/>
           </a:xfrm>
           <a:prstGeom prst="rect">
             <a:avLst/>
@@ -2047,11 +1727,50 @@
           <a:bodyPr wrap="square" lIns="0" tIns="0" rIns="0" bIns="0" rtlCol="0" anchor="ctr"/>
           <a:lstStyle/>
           <a:p>
-            <a:pPr algn="ctr" indent="0" marL="0">
+            <a:pPr marL="0" indent="0">
               <a:buNone/>
             </a:pPr>
             <a:r>
-              <a:rPr lang="en-US" sz="900" i="1" dirty="0">
+              <a:rPr lang="en-US" sz="1000" b="1" dirty="0">
+                <a:solidFill>
+                  <a:srgbClr val="1E293B"/>
+                </a:solidFill>
+                <a:latin typeface="Calibri" pitchFamily="34" charset="0"/>
+                <a:ea typeface="Calibri" pitchFamily="34" charset="-122"/>
+                <a:cs typeface="Calibri" pitchFamily="34" charset="-120"/>
+              </a:rPr>
+              <a:t>JS-GNN</a:t>
+            </a:r>
+            <a:endParaRPr lang="en-US" sz="1000" dirty="0"/>
+          </a:p>
+        </p:txBody>
+      </p:sp>
+      <p:sp>
+        <p:nvSpPr>
+          <p:cNvPr id="34" name="Text 25"/>
+          <p:cNvSpPr/>
+          <p:nvPr/>
+        </p:nvSpPr>
+        <p:spPr>
+          <a:xfrm>
+            <a:off x="731520" y="4636008"/>
+            <a:ext cx="2468880" cy="182880"/>
+          </a:xfrm>
+          <a:prstGeom prst="rect">
+            <a:avLst/>
+          </a:prstGeom>
+          <a:noFill/>
+          <a:ln/>
+        </p:spPr>
+        <p:txBody>
+          <a:bodyPr wrap="square" lIns="0" tIns="0" rIns="0" bIns="0" rtlCol="0" anchor="ctr"/>
+          <a:lstStyle/>
+          <a:p>
+            <a:pPr marL="0" indent="0">
+              <a:buNone/>
+            </a:pPr>
+            <a:r>
+              <a:rPr lang="en-US" sz="850" i="1" dirty="0">
                 <a:solidFill>
                   <a:srgbClr val="64748B"/>
                 </a:solidFill>
@@ -2059,15 +1778,164 @@
                 <a:ea typeface="Calibri" pitchFamily="34" charset="-122"/>
                 <a:cs typeface="Calibri" pitchFamily="34" charset="-120"/>
               </a:rPr>
-              <a:t>Test macro-F1 and class-wise F1 across models</a:t>
-            </a:r>
-            <a:endParaRPr lang="en-US" sz="900" dirty="0"/>
+              <a:t>Top-5 Jensen-Shannon neighbors</a:t>
+            </a:r>
+            <a:endParaRPr lang="en-US" sz="850" dirty="0"/>
+          </a:p>
+        </p:txBody>
+      </p:sp>
+      <p:sp>
+        <p:nvSpPr>
+          <p:cNvPr id="35" name="Text 26"/>
+          <p:cNvSpPr/>
+          <p:nvPr/>
+        </p:nvSpPr>
+        <p:spPr>
+          <a:xfrm>
+            <a:off x="301752" y="4956048"/>
+            <a:ext cx="2926080" cy="201168"/>
+          </a:xfrm>
+          <a:prstGeom prst="rect">
+            <a:avLst/>
+          </a:prstGeom>
+          <a:noFill/>
+          <a:ln/>
+        </p:spPr>
+        <p:txBody>
+          <a:bodyPr wrap="square" lIns="0" tIns="0" rIns="0" bIns="0" rtlCol="0" anchor="ctr"/>
+          <a:lstStyle/>
+          <a:p>
+            <a:pPr marL="0" indent="0">
+              <a:buNone/>
+            </a:pPr>
+            <a:r>
+              <a:rPr lang="en-US" sz="850" i="1" dirty="0">
+                <a:solidFill>
+                  <a:srgbClr val="64748B"/>
+                </a:solidFill>
+                <a:latin typeface="Calibri" pitchFamily="34" charset="0"/>
+                <a:ea typeface="Calibri" pitchFamily="34" charset="-122"/>
+                <a:cs typeface="Calibri" pitchFamily="34" charset="-120"/>
+              </a:rPr>
+              <a:t>+ Sector edges on all graph variants</a:t>
+            </a:r>
+            <a:endParaRPr lang="en-US" sz="850" dirty="0"/>
+          </a:p>
+        </p:txBody>
+      </p:sp>
+      <p:sp>
+        <p:nvSpPr>
+          <p:cNvPr id="36" name="Shape 27"/>
+          <p:cNvSpPr/>
+          <p:nvPr/>
+        </p:nvSpPr>
+        <p:spPr>
+          <a:xfrm>
+            <a:off x="228600" y="5202936"/>
+            <a:ext cx="3017520" cy="237744"/>
+          </a:xfrm>
+          <a:prstGeom prst="rect">
+            <a:avLst/>
+          </a:prstGeom>
+          <a:solidFill>
+            <a:srgbClr val="FFF7ED"/>
+          </a:solidFill>
+          <a:ln w="9525">
+            <a:solidFill>
+              <a:srgbClr val="FED7AA"/>
+            </a:solidFill>
+            <a:prstDash val="solid"/>
+          </a:ln>
+        </p:spPr>
+        <p:txBody>
+          <a:bodyPr/>
+          <a:lstStyle/>
+          <a:p>
+            <a:endParaRPr lang="es-ES"/>
+          </a:p>
+        </p:txBody>
+      </p:sp>
+      <p:sp>
+        <p:nvSpPr>
+          <p:cNvPr id="37" name="Text 28"/>
+          <p:cNvSpPr/>
+          <p:nvPr/>
+        </p:nvSpPr>
+        <p:spPr>
+          <a:xfrm>
+            <a:off x="292608" y="5221224"/>
+            <a:ext cx="2880360" cy="182880"/>
+          </a:xfrm>
+          <a:prstGeom prst="rect">
+            <a:avLst/>
+          </a:prstGeom>
+          <a:noFill/>
+          <a:ln/>
+        </p:spPr>
+        <p:txBody>
+          <a:bodyPr wrap="square" lIns="0" tIns="0" rIns="0" bIns="0" rtlCol="0" anchor="ctr"/>
+          <a:lstStyle/>
+          <a:p>
+            <a:pPr marL="0" indent="0">
+              <a:buNone/>
+            </a:pPr>
+            <a:r>
+              <a:rPr lang="en-US" sz="850" dirty="0">
+                <a:solidFill>
+                  <a:srgbClr val="92400E"/>
+                </a:solidFill>
+                <a:latin typeface="Calibri" pitchFamily="34" charset="0"/>
+                <a:ea typeface="Calibri" pitchFamily="34" charset="-122"/>
+                <a:cs typeface="Calibri" pitchFamily="34" charset="-120"/>
+              </a:rPr>
+              <a:t>🔒  Graphs built from train split only</a:t>
+            </a:r>
+            <a:endParaRPr lang="en-US" sz="850" dirty="0"/>
+          </a:p>
+        </p:txBody>
+      </p:sp>
+      <p:sp>
+        <p:nvSpPr>
+          <p:cNvPr id="38" name="Text 29"/>
+          <p:cNvSpPr/>
+          <p:nvPr/>
+        </p:nvSpPr>
+        <p:spPr>
+          <a:xfrm>
+            <a:off x="3474720" y="1143000"/>
+            <a:ext cx="5760720" cy="256032"/>
+          </a:xfrm>
+          <a:prstGeom prst="rect">
+            <a:avLst/>
+          </a:prstGeom>
+          <a:noFill/>
+          <a:ln/>
+        </p:spPr>
+        <p:txBody>
+          <a:bodyPr wrap="square" lIns="0" tIns="0" rIns="0" bIns="0" rtlCol="0" anchor="ctr"/>
+          <a:lstStyle/>
+          <a:p>
+            <a:pPr marL="0" indent="0">
+              <a:buNone/>
+            </a:pPr>
+            <a:r>
+              <a:rPr lang="en-US" sz="800" b="1" kern="0" spc="300" dirty="0">
+                <a:solidFill>
+                  <a:srgbClr val="2563EB"/>
+                </a:solidFill>
+                <a:latin typeface="Calibri" pitchFamily="34" charset="0"/>
+                <a:ea typeface="Calibri" pitchFamily="34" charset="-122"/>
+                <a:cs typeface="Calibri" pitchFamily="34" charset="-120"/>
+              </a:rPr>
+              <a:t>RESULTS</a:t>
+            </a:r>
+            <a:endParaRPr lang="en-US" sz="800" dirty="0"/>
           </a:p>
         </p:txBody>
       </p:sp>
       <p:pic>
         <p:nvPicPr>
-          <p:cNvPr id="39" name="Image 8" descr="/home/claude/training_curves_row.png">    </p:cNvPr>
+          <p:cNvPr id="39" name="Image 7" descr="/home/claude/model_comparison_cropped.png"/>
           <p:cNvPicPr>
             <a:picLocks noChangeAspect="1"/>
           </p:cNvPicPr>
@@ -2081,8 +1949,8 @@
         </p:blipFill>
         <p:spPr>
           <a:xfrm>
-            <a:off x="3474720" y="3920084"/>
-            <a:ext cx="5669280" cy="2117505"/>
+            <a:off x="3337560" y="1389888"/>
+            <a:ext cx="5760720" cy="2187085"/>
           </a:xfrm>
           <a:prstGeom prst="rect">
             <a:avLst/>
@@ -2091,14 +1959,14 @@
       </p:pic>
       <p:sp>
         <p:nvSpPr>
-          <p:cNvPr id="40" name="Text 29"/>
-          <p:cNvSpPr/>
-          <p:nvPr/>
-        </p:nvSpPr>
-        <p:spPr>
-          <a:xfrm>
-            <a:off x="3474720" y="6074165"/>
-            <a:ext cx="5669280" cy="182880"/>
+          <p:cNvPr id="40" name="Text 30"/>
+          <p:cNvSpPr/>
+          <p:nvPr/>
+        </p:nvSpPr>
+        <p:spPr>
+          <a:xfrm>
+            <a:off x="3337560" y="3613549"/>
+            <a:ext cx="5760720" cy="201168"/>
           </a:xfrm>
           <a:prstGeom prst="rect">
             <a:avLst/>
@@ -2110,7 +1978,7 @@
           <a:bodyPr wrap="square" lIns="0" tIns="0" rIns="0" bIns="0" rtlCol="0" anchor="ctr"/>
           <a:lstStyle/>
           <a:p>
-            <a:pPr algn="ctr" indent="0" marL="0">
+            <a:pPr marL="0" indent="0" algn="ctr">
               <a:buNone/>
             </a:pPr>
             <a:r>
@@ -2122,22 +1990,46 @@
                 <a:ea typeface="Calibri" pitchFamily="34" charset="-122"/>
                 <a:cs typeface="Calibri" pitchFamily="34" charset="-120"/>
               </a:rPr>
-              <a:t>Training loss and validation macro-F1 over epochs</a:t>
+              <a:t>Test macro-F1 and class-wise F1 across models</a:t>
             </a:r>
             <a:endParaRPr lang="en-US" sz="900" dirty="0"/>
           </a:p>
         </p:txBody>
       </p:sp>
-      <p:sp>
-        <p:nvSpPr>
-          <p:cNvPr id="41" name="Text 30"/>
-          <p:cNvSpPr/>
-          <p:nvPr/>
-        </p:nvSpPr>
-        <p:spPr>
-          <a:xfrm>
-            <a:off x="9372600" y="1143000"/>
-            <a:ext cx="2560320" cy="256032"/>
+      <p:pic>
+        <p:nvPicPr>
+          <p:cNvPr id="41" name="Image 8" descr="/home/claude/training_curves_cropped.png"/>
+          <p:cNvPicPr>
+            <a:picLocks noChangeAspect="1"/>
+          </p:cNvPicPr>
+          <p:nvPr/>
+        </p:nvPicPr>
+        <p:blipFill>
+          <a:blip r:embed="rId10"/>
+          <a:stretch>
+            <a:fillRect/>
+          </a:stretch>
+        </p:blipFill>
+        <p:spPr>
+          <a:xfrm>
+            <a:off x="3337560" y="3869581"/>
+            <a:ext cx="5760720" cy="2033217"/>
+          </a:xfrm>
+          <a:prstGeom prst="rect">
+            <a:avLst/>
+          </a:prstGeom>
+        </p:spPr>
+      </p:pic>
+      <p:sp>
+        <p:nvSpPr>
+          <p:cNvPr id="42" name="Text 31"/>
+          <p:cNvSpPr/>
+          <p:nvPr/>
+        </p:nvSpPr>
+        <p:spPr>
+          <a:xfrm>
+            <a:off x="3337560" y="5939375"/>
+            <a:ext cx="5760720" cy="182880"/>
           </a:xfrm>
           <a:prstGeom prst="rect">
             <a:avLst/>
@@ -2149,11 +2041,50 @@
           <a:bodyPr wrap="square" lIns="0" tIns="0" rIns="0" bIns="0" rtlCol="0" anchor="ctr"/>
           <a:lstStyle/>
           <a:p>
-            <a:pPr indent="0" marL="0">
+            <a:pPr marL="0" indent="0" algn="ctr">
               <a:buNone/>
             </a:pPr>
             <a:r>
-              <a:rPr lang="en-US" sz="800" b="1" spc="300" kern="0" dirty="0">
+              <a:rPr lang="en-US" sz="900" i="1" dirty="0">
+                <a:solidFill>
+                  <a:srgbClr val="64748B"/>
+                </a:solidFill>
+                <a:latin typeface="Calibri" pitchFamily="34" charset="0"/>
+                <a:ea typeface="Calibri" pitchFamily="34" charset="-122"/>
+                <a:cs typeface="Calibri" pitchFamily="34" charset="-120"/>
+              </a:rPr>
+              <a:t>Training loss and validation macro-F1 over epochs</a:t>
+            </a:r>
+            <a:endParaRPr lang="en-US" sz="900" dirty="0"/>
+          </a:p>
+        </p:txBody>
+      </p:sp>
+      <p:sp>
+        <p:nvSpPr>
+          <p:cNvPr id="43" name="Text 32"/>
+          <p:cNvSpPr/>
+          <p:nvPr/>
+        </p:nvSpPr>
+        <p:spPr>
+          <a:xfrm>
+            <a:off x="9427464" y="2324245"/>
+            <a:ext cx="2560320" cy="256032"/>
+          </a:xfrm>
+          <a:prstGeom prst="rect">
+            <a:avLst/>
+          </a:prstGeom>
+          <a:noFill/>
+          <a:ln/>
+        </p:spPr>
+        <p:txBody>
+          <a:bodyPr wrap="square" lIns="0" tIns="0" rIns="0" bIns="0" rtlCol="0" anchor="ctr"/>
+          <a:lstStyle/>
+          <a:p>
+            <a:pPr marL="0" indent="0">
+              <a:buNone/>
+            </a:pPr>
+            <a:r>
+              <a:rPr lang="en-US" sz="800" b="1" kern="0" spc="300" dirty="0">
                 <a:solidFill>
                   <a:srgbClr val="2563EB"/>
                 </a:solidFill>
@@ -2169,13 +2100,13 @@
       </p:sp>
       <p:sp>
         <p:nvSpPr>
-          <p:cNvPr id="42" name="Shape 31"/>
-          <p:cNvSpPr/>
-          <p:nvPr/>
-        </p:nvSpPr>
-        <p:spPr>
-          <a:xfrm>
-            <a:off x="9372600" y="1463040"/>
+          <p:cNvPr id="44" name="Shape 33"/>
+          <p:cNvSpPr/>
+          <p:nvPr/>
+        </p:nvSpPr>
+        <p:spPr>
+          <a:xfrm>
+            <a:off x="9427464" y="2644285"/>
             <a:ext cx="2560320" cy="457200"/>
           </a:xfrm>
           <a:prstGeom prst="rect">
@@ -2191,16 +2122,23 @@
             <a:prstDash val="solid"/>
           </a:ln>
         </p:spPr>
-      </p:sp>
-      <p:sp>
-        <p:nvSpPr>
-          <p:cNvPr id="43" name="Shape 32"/>
-          <p:cNvSpPr/>
-          <p:nvPr/>
-        </p:nvSpPr>
-        <p:spPr>
-          <a:xfrm>
-            <a:off x="9372600" y="1463040"/>
+        <p:txBody>
+          <a:bodyPr/>
+          <a:lstStyle/>
+          <a:p>
+            <a:endParaRPr lang="es-ES"/>
+          </a:p>
+        </p:txBody>
+      </p:sp>
+      <p:sp>
+        <p:nvSpPr>
+          <p:cNvPr id="45" name="Shape 34"/>
+          <p:cNvSpPr/>
+          <p:nvPr/>
+        </p:nvSpPr>
+        <p:spPr>
+          <a:xfrm>
+            <a:off x="9427464" y="2644285"/>
             <a:ext cx="54864" cy="457200"/>
           </a:xfrm>
           <a:prstGeom prst="rect">
@@ -2216,16 +2154,23 @@
             <a:prstDash val="solid"/>
           </a:ln>
         </p:spPr>
-      </p:sp>
-      <p:sp>
-        <p:nvSpPr>
-          <p:cNvPr id="44" name="Text 33"/>
-          <p:cNvSpPr/>
-          <p:nvPr/>
-        </p:nvSpPr>
-        <p:spPr>
-          <a:xfrm>
-            <a:off x="9491472" y="1536192"/>
+        <p:txBody>
+          <a:bodyPr/>
+          <a:lstStyle/>
+          <a:p>
+            <a:endParaRPr lang="es-ES"/>
+          </a:p>
+        </p:txBody>
+      </p:sp>
+      <p:sp>
+        <p:nvSpPr>
+          <p:cNvPr id="46" name="Text 35"/>
+          <p:cNvSpPr/>
+          <p:nvPr/>
+        </p:nvSpPr>
+        <p:spPr>
+          <a:xfrm>
+            <a:off x="9546336" y="2717437"/>
             <a:ext cx="1645920" cy="182880"/>
           </a:xfrm>
           <a:prstGeom prst="rect">
@@ -2238,7 +2183,7 @@
           <a:bodyPr wrap="square" lIns="0" tIns="0" rIns="0" bIns="0" rtlCol="0" anchor="ctr"/>
           <a:lstStyle/>
           <a:p>
-            <a:pPr indent="0" marL="0">
+            <a:pPr marL="0" indent="0">
               <a:buNone/>
             </a:pPr>
             <a:r>
@@ -2258,13 +2203,13 @@
       </p:sp>
       <p:sp>
         <p:nvSpPr>
-          <p:cNvPr id="45" name="Text 34"/>
-          <p:cNvSpPr/>
-          <p:nvPr/>
-        </p:nvSpPr>
-        <p:spPr>
-          <a:xfrm>
-            <a:off x="11018520" y="1536192"/>
+          <p:cNvPr id="47" name="Text 36"/>
+          <p:cNvSpPr/>
+          <p:nvPr/>
+        </p:nvSpPr>
+        <p:spPr>
+          <a:xfrm>
+            <a:off x="11073384" y="2717437"/>
             <a:ext cx="822960" cy="182880"/>
           </a:xfrm>
           <a:prstGeom prst="rect">
@@ -2277,7 +2222,7 @@
           <a:bodyPr wrap="square" lIns="0" tIns="0" rIns="0" bIns="0" rtlCol="0" anchor="ctr"/>
           <a:lstStyle/>
           <a:p>
-            <a:pPr algn="r" indent="0" marL="0">
+            <a:pPr marL="0" indent="0" algn="r">
               <a:buNone/>
             </a:pPr>
             <a:r>
@@ -2297,13 +2242,13 @@
       </p:sp>
       <p:sp>
         <p:nvSpPr>
-          <p:cNvPr id="46" name="Text 35"/>
-          <p:cNvSpPr/>
-          <p:nvPr/>
-        </p:nvSpPr>
-        <p:spPr>
-          <a:xfrm>
-            <a:off x="9491472" y="1719072"/>
+          <p:cNvPr id="48" name="Text 37"/>
+          <p:cNvSpPr/>
+          <p:nvPr/>
+        </p:nvSpPr>
+        <p:spPr>
+          <a:xfrm>
+            <a:off x="9546336" y="2900317"/>
             <a:ext cx="1280160" cy="146304"/>
           </a:xfrm>
           <a:prstGeom prst="rect">
@@ -2316,7 +2261,7 @@
           <a:bodyPr wrap="square" lIns="0" tIns="0" rIns="0" bIns="0" rtlCol="0" anchor="ctr"/>
           <a:lstStyle/>
           <a:p>
-            <a:pPr indent="0" marL="0">
+            <a:pPr marL="0" indent="0">
               <a:buNone/>
             </a:pPr>
             <a:r>
@@ -2336,13 +2281,13 @@
       </p:sp>
       <p:sp>
         <p:nvSpPr>
-          <p:cNvPr id="47" name="Shape 36"/>
-          <p:cNvSpPr/>
-          <p:nvPr/>
-        </p:nvSpPr>
-        <p:spPr>
-          <a:xfrm>
-            <a:off x="9372600" y="1975104"/>
+          <p:cNvPr id="49" name="Shape 38"/>
+          <p:cNvSpPr/>
+          <p:nvPr/>
+        </p:nvSpPr>
+        <p:spPr>
+          <a:xfrm>
+            <a:off x="9427464" y="3156349"/>
             <a:ext cx="2560320" cy="457200"/>
           </a:xfrm>
           <a:prstGeom prst="rect">
@@ -2358,16 +2303,23 @@
             <a:prstDash val="solid"/>
           </a:ln>
         </p:spPr>
-      </p:sp>
-      <p:sp>
-        <p:nvSpPr>
-          <p:cNvPr id="48" name="Shape 37"/>
-          <p:cNvSpPr/>
-          <p:nvPr/>
-        </p:nvSpPr>
-        <p:spPr>
-          <a:xfrm>
-            <a:off x="9372600" y="1975104"/>
+        <p:txBody>
+          <a:bodyPr/>
+          <a:lstStyle/>
+          <a:p>
+            <a:endParaRPr lang="es-ES"/>
+          </a:p>
+        </p:txBody>
+      </p:sp>
+      <p:sp>
+        <p:nvSpPr>
+          <p:cNvPr id="50" name="Shape 39"/>
+          <p:cNvSpPr/>
+          <p:nvPr/>
+        </p:nvSpPr>
+        <p:spPr>
+          <a:xfrm>
+            <a:off x="9427464" y="3156349"/>
             <a:ext cx="54864" cy="457200"/>
           </a:xfrm>
           <a:prstGeom prst="rect">
@@ -2383,16 +2335,23 @@
             <a:prstDash val="solid"/>
           </a:ln>
         </p:spPr>
-      </p:sp>
-      <p:sp>
-        <p:nvSpPr>
-          <p:cNvPr id="49" name="Text 38"/>
-          <p:cNvSpPr/>
-          <p:nvPr/>
-        </p:nvSpPr>
-        <p:spPr>
-          <a:xfrm>
-            <a:off x="9491472" y="2048256"/>
+        <p:txBody>
+          <a:bodyPr/>
+          <a:lstStyle/>
+          <a:p>
+            <a:endParaRPr lang="es-ES"/>
+          </a:p>
+        </p:txBody>
+      </p:sp>
+      <p:sp>
+        <p:nvSpPr>
+          <p:cNvPr id="51" name="Text 40"/>
+          <p:cNvSpPr/>
+          <p:nvPr/>
+        </p:nvSpPr>
+        <p:spPr>
+          <a:xfrm>
+            <a:off x="9546336" y="3229501"/>
             <a:ext cx="1645920" cy="182880"/>
           </a:xfrm>
           <a:prstGeom prst="rect">
@@ -2405,7 +2364,7 @@
           <a:bodyPr wrap="square" lIns="0" tIns="0" rIns="0" bIns="0" rtlCol="0" anchor="ctr"/>
           <a:lstStyle/>
           <a:p>
-            <a:pPr indent="0" marL="0">
+            <a:pPr marL="0" indent="0">
               <a:buNone/>
             </a:pPr>
             <a:r>
@@ -2425,13 +2384,13 @@
       </p:sp>
       <p:sp>
         <p:nvSpPr>
-          <p:cNvPr id="50" name="Text 39"/>
-          <p:cNvSpPr/>
-          <p:nvPr/>
-        </p:nvSpPr>
-        <p:spPr>
-          <a:xfrm>
-            <a:off x="11018520" y="2048256"/>
+          <p:cNvPr id="52" name="Text 41"/>
+          <p:cNvSpPr/>
+          <p:nvPr/>
+        </p:nvSpPr>
+        <p:spPr>
+          <a:xfrm>
+            <a:off x="11073384" y="3229501"/>
             <a:ext cx="822960" cy="182880"/>
           </a:xfrm>
           <a:prstGeom prst="rect">
@@ -2444,7 +2403,7 @@
           <a:bodyPr wrap="square" lIns="0" tIns="0" rIns="0" bIns="0" rtlCol="0" anchor="ctr"/>
           <a:lstStyle/>
           <a:p>
-            <a:pPr algn="r" indent="0" marL="0">
+            <a:pPr marL="0" indent="0" algn="r">
               <a:buNone/>
             </a:pPr>
             <a:r>
@@ -2464,13 +2423,13 @@
       </p:sp>
       <p:sp>
         <p:nvSpPr>
-          <p:cNvPr id="51" name="Text 40"/>
-          <p:cNvSpPr/>
-          <p:nvPr/>
-        </p:nvSpPr>
-        <p:spPr>
-          <a:xfrm>
-            <a:off x="9491472" y="2231136"/>
+          <p:cNvPr id="53" name="Text 42"/>
+          <p:cNvSpPr/>
+          <p:nvPr/>
+        </p:nvSpPr>
+        <p:spPr>
+          <a:xfrm>
+            <a:off x="9546336" y="3412381"/>
             <a:ext cx="1280160" cy="146304"/>
           </a:xfrm>
           <a:prstGeom prst="rect">
@@ -2483,7 +2442,7 @@
           <a:bodyPr wrap="square" lIns="0" tIns="0" rIns="0" bIns="0" rtlCol="0" anchor="ctr"/>
           <a:lstStyle/>
           <a:p>
-            <a:pPr indent="0" marL="0">
+            <a:pPr marL="0" indent="0">
               <a:buNone/>
             </a:pPr>
             <a:r>
@@ -2503,13 +2462,13 @@
       </p:sp>
       <p:sp>
         <p:nvSpPr>
-          <p:cNvPr id="52" name="Shape 41"/>
-          <p:cNvSpPr/>
-          <p:nvPr/>
-        </p:nvSpPr>
-        <p:spPr>
-          <a:xfrm>
-            <a:off x="9372600" y="2487168"/>
+          <p:cNvPr id="54" name="Shape 43"/>
+          <p:cNvSpPr/>
+          <p:nvPr/>
+        </p:nvSpPr>
+        <p:spPr>
+          <a:xfrm>
+            <a:off x="9427464" y="3668413"/>
             <a:ext cx="2560320" cy="457200"/>
           </a:xfrm>
           <a:prstGeom prst="rect">
@@ -2525,16 +2484,23 @@
             <a:prstDash val="solid"/>
           </a:ln>
         </p:spPr>
-      </p:sp>
-      <p:sp>
-        <p:nvSpPr>
-          <p:cNvPr id="53" name="Text 42"/>
-          <p:cNvSpPr/>
-          <p:nvPr/>
-        </p:nvSpPr>
-        <p:spPr>
-          <a:xfrm>
-            <a:off x="9491472" y="2560320"/>
+        <p:txBody>
+          <a:bodyPr/>
+          <a:lstStyle/>
+          <a:p>
+            <a:endParaRPr lang="es-ES"/>
+          </a:p>
+        </p:txBody>
+      </p:sp>
+      <p:sp>
+        <p:nvSpPr>
+          <p:cNvPr id="55" name="Text 44"/>
+          <p:cNvSpPr/>
+          <p:nvPr/>
+        </p:nvSpPr>
+        <p:spPr>
+          <a:xfrm>
+            <a:off x="9546336" y="3741565"/>
             <a:ext cx="1645920" cy="182880"/>
           </a:xfrm>
           <a:prstGeom prst="rect">
@@ -2547,7 +2513,7 @@
           <a:bodyPr wrap="square" lIns="0" tIns="0" rIns="0" bIns="0" rtlCol="0" anchor="ctr"/>
           <a:lstStyle/>
           <a:p>
-            <a:pPr indent="0" marL="0">
+            <a:pPr marL="0" indent="0">
               <a:buNone/>
             </a:pPr>
             <a:r>
@@ -2567,13 +2533,13 @@
       </p:sp>
       <p:sp>
         <p:nvSpPr>
-          <p:cNvPr id="54" name="Text 43"/>
-          <p:cNvSpPr/>
-          <p:nvPr/>
-        </p:nvSpPr>
-        <p:spPr>
-          <a:xfrm>
-            <a:off x="11018520" y="2560320"/>
+          <p:cNvPr id="56" name="Text 45"/>
+          <p:cNvSpPr/>
+          <p:nvPr/>
+        </p:nvSpPr>
+        <p:spPr>
+          <a:xfrm>
+            <a:off x="11073384" y="3741565"/>
             <a:ext cx="822960" cy="182880"/>
           </a:xfrm>
           <a:prstGeom prst="rect">
@@ -2586,7 +2552,7 @@
           <a:bodyPr wrap="square" lIns="0" tIns="0" rIns="0" bIns="0" rtlCol="0" anchor="ctr"/>
           <a:lstStyle/>
           <a:p>
-            <a:pPr algn="r" indent="0" marL="0">
+            <a:pPr marL="0" indent="0" algn="r">
               <a:buNone/>
             </a:pPr>
             <a:r>
@@ -2606,13 +2572,13 @@
       </p:sp>
       <p:sp>
         <p:nvSpPr>
-          <p:cNvPr id="55" name="Shape 44"/>
-          <p:cNvSpPr/>
-          <p:nvPr/>
-        </p:nvSpPr>
-        <p:spPr>
-          <a:xfrm>
-            <a:off x="9372600" y="2999232"/>
+          <p:cNvPr id="57" name="Shape 46"/>
+          <p:cNvSpPr/>
+          <p:nvPr/>
+        </p:nvSpPr>
+        <p:spPr>
+          <a:xfrm>
+            <a:off x="9427464" y="4180477"/>
             <a:ext cx="2560320" cy="457200"/>
           </a:xfrm>
           <a:prstGeom prst="rect">
@@ -2628,16 +2594,23 @@
             <a:prstDash val="solid"/>
           </a:ln>
         </p:spPr>
-      </p:sp>
-      <p:sp>
-        <p:nvSpPr>
-          <p:cNvPr id="56" name="Text 45"/>
-          <p:cNvSpPr/>
-          <p:nvPr/>
-        </p:nvSpPr>
-        <p:spPr>
-          <a:xfrm>
-            <a:off x="9491472" y="3072384"/>
+        <p:txBody>
+          <a:bodyPr/>
+          <a:lstStyle/>
+          <a:p>
+            <a:endParaRPr lang="es-ES"/>
+          </a:p>
+        </p:txBody>
+      </p:sp>
+      <p:sp>
+        <p:nvSpPr>
+          <p:cNvPr id="58" name="Text 47"/>
+          <p:cNvSpPr/>
+          <p:nvPr/>
+        </p:nvSpPr>
+        <p:spPr>
+          <a:xfrm>
+            <a:off x="9546336" y="4253629"/>
             <a:ext cx="1645920" cy="182880"/>
           </a:xfrm>
           <a:prstGeom prst="rect">
@@ -2650,7 +2623,7 @@
           <a:bodyPr wrap="square" lIns="0" tIns="0" rIns="0" bIns="0" rtlCol="0" anchor="ctr"/>
           <a:lstStyle/>
           <a:p>
-            <a:pPr indent="0" marL="0">
+            <a:pPr marL="0" indent="0">
               <a:buNone/>
             </a:pPr>
             <a:r>
@@ -2670,13 +2643,13 @@
       </p:sp>
       <p:sp>
         <p:nvSpPr>
-          <p:cNvPr id="57" name="Text 46"/>
-          <p:cNvSpPr/>
-          <p:nvPr/>
-        </p:nvSpPr>
-        <p:spPr>
-          <a:xfrm>
-            <a:off x="11018520" y="3072384"/>
+          <p:cNvPr id="59" name="Text 48"/>
+          <p:cNvSpPr/>
+          <p:nvPr/>
+        </p:nvSpPr>
+        <p:spPr>
+          <a:xfrm>
+            <a:off x="11073384" y="4253629"/>
             <a:ext cx="822960" cy="182880"/>
           </a:xfrm>
           <a:prstGeom prst="rect">
@@ -2689,7 +2662,7 @@
           <a:bodyPr wrap="square" lIns="0" tIns="0" rIns="0" bIns="0" rtlCol="0" anchor="ctr"/>
           <a:lstStyle/>
           <a:p>
-            <a:pPr algn="r" indent="0" marL="0">
+            <a:pPr marL="0" indent="0" algn="r">
               <a:buNone/>
             </a:pPr>
             <a:r>
@@ -2709,7 +2682,7 @@
       </p:sp>
       <p:sp>
         <p:nvSpPr>
-          <p:cNvPr id="58" name="Shape 47"/>
+          <p:cNvPr id="60" name="Shape 49"/>
           <p:cNvSpPr/>
           <p:nvPr/>
         </p:nvSpPr>
@@ -2731,10 +2704,17 @@
             <a:prstDash val="solid"/>
           </a:ln>
         </p:spPr>
-      </p:sp>
-      <p:sp>
-        <p:nvSpPr>
-          <p:cNvPr id="59" name="Text 48"/>
+        <p:txBody>
+          <a:bodyPr/>
+          <a:lstStyle/>
+          <a:p>
+            <a:endParaRPr lang="es-ES"/>
+          </a:p>
+        </p:txBody>
+      </p:sp>
+      <p:sp>
+        <p:nvSpPr>
+          <p:cNvPr id="61" name="Text 50"/>
           <p:cNvSpPr/>
           <p:nvPr/>
         </p:nvSpPr>
@@ -2753,7 +2733,7 @@
           <a:bodyPr wrap="square" lIns="0" tIns="0" rIns="0" bIns="0" rtlCol="0" anchor="ctr"/>
           <a:lstStyle/>
           <a:p>
-            <a:pPr indent="0" marL="0">
+            <a:pPr marL="0" indent="0">
               <a:buNone/>
             </a:pPr>
             <a:r>
@@ -2767,9 +2747,6 @@
               </a:rPr>
               <a:t>①  </a:t>
             </a:r>
-            <a:pPr indent="0" marL="0">
-              <a:buNone/>
-            </a:pPr>
             <a:r>
               <a:rPr lang="en-US" sz="1050" dirty="0">
                 <a:solidFill>
@@ -2787,7 +2764,7 @@
       </p:sp>
       <p:sp>
         <p:nvSpPr>
-          <p:cNvPr id="60" name="Shape 49"/>
+          <p:cNvPr id="62" name="Shape 51"/>
           <p:cNvSpPr/>
           <p:nvPr/>
         </p:nvSpPr>
@@ -2809,10 +2786,17 @@
             <a:prstDash val="solid"/>
           </a:ln>
         </p:spPr>
-      </p:sp>
-      <p:sp>
-        <p:nvSpPr>
-          <p:cNvPr id="61" name="Text 50"/>
+        <p:txBody>
+          <a:bodyPr/>
+          <a:lstStyle/>
+          <a:p>
+            <a:endParaRPr lang="es-ES"/>
+          </a:p>
+        </p:txBody>
+      </p:sp>
+      <p:sp>
+        <p:nvSpPr>
+          <p:cNvPr id="63" name="Text 52"/>
           <p:cNvSpPr/>
           <p:nvPr/>
         </p:nvSpPr>
@@ -2831,7 +2815,7 @@
           <a:bodyPr wrap="square" lIns="0" tIns="0" rIns="0" bIns="0" rtlCol="0" anchor="ctr"/>
           <a:lstStyle/>
           <a:p>
-            <a:pPr indent="0" marL="0">
+            <a:pPr marL="0" indent="0">
               <a:buNone/>
             </a:pPr>
             <a:r>
@@ -2845,9 +2829,6 @@
               </a:rPr>
               <a:t>②  </a:t>
             </a:r>
-            <a:pPr indent="0" marL="0">
-              <a:buNone/>
-            </a:pPr>
             <a:r>
               <a:rPr lang="en-US" sz="1050" dirty="0">
                 <a:solidFill>
@@ -2865,7 +2846,7 @@
       </p:sp>
       <p:sp>
         <p:nvSpPr>
-          <p:cNvPr id="62" name="Shape 51"/>
+          <p:cNvPr id="64" name="Shape 53"/>
           <p:cNvSpPr/>
           <p:nvPr/>
         </p:nvSpPr>
@@ -2887,10 +2868,17 @@
             <a:prstDash val="solid"/>
           </a:ln>
         </p:spPr>
-      </p:sp>
-      <p:sp>
-        <p:nvSpPr>
-          <p:cNvPr id="63" name="Text 52"/>
+        <p:txBody>
+          <a:bodyPr/>
+          <a:lstStyle/>
+          <a:p>
+            <a:endParaRPr lang="es-ES"/>
+          </a:p>
+        </p:txBody>
+      </p:sp>
+      <p:sp>
+        <p:nvSpPr>
+          <p:cNvPr id="65" name="Text 54"/>
           <p:cNvSpPr/>
           <p:nvPr/>
         </p:nvSpPr>
@@ -2909,7 +2897,7 @@
           <a:bodyPr wrap="square" lIns="0" tIns="0" rIns="0" bIns="0" rtlCol="0" anchor="ctr"/>
           <a:lstStyle/>
           <a:p>
-            <a:pPr indent="0" marL="0">
+            <a:pPr marL="0" indent="0">
               <a:buNone/>
             </a:pPr>
             <a:r>
@@ -2923,9 +2911,6 @@
               </a:rPr>
               <a:t>③  </a:t>
             </a:r>
-            <a:pPr indent="0" marL="0">
-              <a:buNone/>
-            </a:pPr>
             <a:r>
               <a:rPr lang="en-US" sz="1050" dirty="0">
                 <a:solidFill>
@@ -3242,4 +3227,319 @@
     </a:ext>
   </a:extLst>
 </a:theme>
+</file>
+
+<file path=ppt/theme/theme2.xml><?xml version="1.0" encoding="utf-8"?>
+<a:theme xmlns:a="http://schemas.openxmlformats.org/drawingml/2006/main" name="Office Theme">
+  <a:themeElements>
+    <a:clrScheme name="Office">
+      <a:dk1>
+        <a:sysClr val="windowText" lastClr="000000"/>
+      </a:dk1>
+      <a:lt1>
+        <a:sysClr val="window" lastClr="FFFFFF"/>
+      </a:lt1>
+      <a:dk2>
+        <a:srgbClr val="0E2841"/>
+      </a:dk2>
+      <a:lt2>
+        <a:srgbClr val="E8E8E8"/>
+      </a:lt2>
+      <a:accent1>
+        <a:srgbClr val="156082"/>
+      </a:accent1>
+      <a:accent2>
+        <a:srgbClr val="E97132"/>
+      </a:accent2>
+      <a:accent3>
+        <a:srgbClr val="196B24"/>
+      </a:accent3>
+      <a:accent4>
+        <a:srgbClr val="0F9ED5"/>
+      </a:accent4>
+      <a:accent5>
+        <a:srgbClr val="A02B93"/>
+      </a:accent5>
+      <a:accent6>
+        <a:srgbClr val="4EA72E"/>
+      </a:accent6>
+      <a:hlink>
+        <a:srgbClr val="467886"/>
+      </a:hlink>
+      <a:folHlink>
+        <a:srgbClr val="96607D"/>
+      </a:folHlink>
+    </a:clrScheme>
+    <a:fontScheme name="Office">
+      <a:majorFont>
+        <a:latin typeface="Aptos Display" panose="02110004020202020204"/>
+        <a:ea typeface=""/>
+        <a:cs typeface=""/>
+        <a:font script="Jpan" typeface="游ゴシック Light"/>
+        <a:font script="Hang" typeface="맑은 고딕"/>
+        <a:font script="Hans" typeface="等线 Light"/>
+        <a:font script="Hant" typeface="新細明體"/>
+        <a:font script="Arab" typeface="Times New Roman"/>
+        <a:font script="Hebr" typeface="Times New Roman"/>
+        <a:font script="Thai" typeface="Angsana New"/>
+        <a:font script="Ethi" typeface="Nyala"/>
+        <a:font script="Beng" typeface="Vrinda"/>
+        <a:font script="Gujr" typeface="Shruti"/>
+        <a:font script="Khmr" typeface="MoolBoran"/>
+        <a:font script="Knda" typeface="Tunga"/>
+        <a:font script="Guru" typeface="Raavi"/>
+        <a:font script="Cans" typeface="Euphemia"/>
+        <a:font script="Cher" typeface="Plantagenet Cherokee"/>
+        <a:font script="Yiii" typeface="Microsoft Yi Baiti"/>
+        <a:font script="Tibt" typeface="Microsoft Himalaya"/>
+        <a:font script="Thaa" typeface="MV Boli"/>
+        <a:font script="Deva" typeface="Mangal"/>
+        <a:font script="Telu" typeface="Gautami"/>
+        <a:font script="Taml" typeface="Latha"/>
+        <a:font script="Syrc" typeface="Estrangelo Edessa"/>
+        <a:font script="Orya" typeface="Kalinga"/>
+        <a:font script="Mlym" typeface="Kartika"/>
+        <a:font script="Laoo" typeface="DokChampa"/>
+        <a:font script="Sinh" typeface="Iskoola Pota"/>
+        <a:font script="Mong" typeface="Mongolian Baiti"/>
+        <a:font script="Viet" typeface="Times New Roman"/>
+        <a:font script="Uigh" typeface="Microsoft Uighur"/>
+        <a:font script="Geor" typeface="Sylfaen"/>
+        <a:font script="Armn" typeface="Arial"/>
+        <a:font script="Bugi" typeface="Leelawadee UI"/>
+        <a:font script="Bopo" typeface="Microsoft JhengHei"/>
+        <a:font script="Java" typeface="Javanese Text"/>
+        <a:font script="Lisu" typeface="Segoe UI"/>
+        <a:font script="Mymr" typeface="Myanmar Text"/>
+        <a:font script="Nkoo" typeface="Ebrima"/>
+        <a:font script="Olck" typeface="Nirmala UI"/>
+        <a:font script="Osma" typeface="Ebrima"/>
+        <a:font script="Phag" typeface="Phagspa"/>
+        <a:font script="Syrn" typeface="Estrangelo Edessa"/>
+        <a:font script="Syrj" typeface="Estrangelo Edessa"/>
+        <a:font script="Syre" typeface="Estrangelo Edessa"/>
+        <a:font script="Sora" typeface="Nirmala UI"/>
+        <a:font script="Tale" typeface="Microsoft Tai Le"/>
+        <a:font script="Talu" typeface="Microsoft New Tai Lue"/>
+        <a:font script="Tfng" typeface="Ebrima"/>
+      </a:majorFont>
+      <a:minorFont>
+        <a:latin typeface="Aptos" panose="02110004020202020204"/>
+        <a:ea typeface=""/>
+        <a:cs typeface=""/>
+        <a:font script="Jpan" typeface="游ゴシック"/>
+        <a:font script="Hang" typeface="맑은 고딕"/>
+        <a:font script="Hans" typeface="等线"/>
+        <a:font script="Hant" typeface="新細明體"/>
+        <a:font script="Arab" typeface="Arial"/>
+        <a:font script="Hebr" typeface="Arial"/>
+        <a:font script="Thai" typeface="Cordia New"/>
+        <a:font script="Ethi" typeface="Nyala"/>
+        <a:font script="Beng" typeface="Vrinda"/>
+        <a:font script="Gujr" typeface="Shruti"/>
+        <a:font script="Khmr" typeface="DaunPenh"/>
+        <a:font script="Knda" typeface="Tunga"/>
+        <a:font script="Guru" typeface="Raavi"/>
+        <a:font script="Cans" typeface="Euphemia"/>
+        <a:font script="Cher" typeface="Plantagenet Cherokee"/>
+        <a:font script="Yiii" typeface="Microsoft Yi Baiti"/>
+        <a:font script="Tibt" typeface="Microsoft Himalaya"/>
+        <a:font script="Thaa" typeface="MV Boli"/>
+        <a:font script="Deva" typeface="Mangal"/>
+        <a:font script="Telu" typeface="Gautami"/>
+        <a:font script="Taml" typeface="Latha"/>
+        <a:font script="Syrc" typeface="Estrangelo Edessa"/>
+        <a:font script="Orya" typeface="Kalinga"/>
+        <a:font script="Mlym" typeface="Kartika"/>
+        <a:font script="Laoo" typeface="DokChampa"/>
+        <a:font script="Sinh" typeface="Iskoola Pota"/>
+        <a:font script="Mong" typeface="Mongolian Baiti"/>
+        <a:font script="Viet" typeface="Arial"/>
+        <a:font script="Uigh" typeface="Microsoft Uighur"/>
+        <a:font script="Geor" typeface="Sylfaen"/>
+        <a:font script="Armn" typeface="Arial"/>
+        <a:font script="Bugi" typeface="Leelawadee UI"/>
+        <a:font script="Bopo" typeface="Microsoft JhengHei"/>
+        <a:font script="Java" typeface="Javanese Text"/>
+        <a:font script="Lisu" typeface="Segoe UI"/>
+        <a:font script="Mymr" typeface="Myanmar Text"/>
+        <a:font script="Nkoo" typeface="Ebrima"/>
+        <a:font script="Olck" typeface="Nirmala UI"/>
+        <a:font script="Osma" typeface="Ebrima"/>
+        <a:font script="Phag" typeface="Phagspa"/>
+        <a:font script="Syrn" typeface="Estrangelo Edessa"/>
+        <a:font script="Syrj" typeface="Estrangelo Edessa"/>
+        <a:font script="Syre" typeface="Estrangelo Edessa"/>
+        <a:font script="Sora" typeface="Nirmala UI"/>
+        <a:font script="Tale" typeface="Microsoft Tai Le"/>
+        <a:font script="Talu" typeface="Microsoft New Tai Lue"/>
+        <a:font script="Tfng" typeface="Ebrima"/>
+      </a:minorFont>
+    </a:fontScheme>
+    <a:fmtScheme name="Office">
+      <a:fillStyleLst>
+        <a:solidFill>
+          <a:schemeClr val="phClr"/>
+        </a:solidFill>
+        <a:gradFill rotWithShape="1">
+          <a:gsLst>
+            <a:gs pos="0">
+              <a:schemeClr val="phClr">
+                <a:lumMod val="110000"/>
+                <a:satMod val="105000"/>
+                <a:tint val="67000"/>
+              </a:schemeClr>
+            </a:gs>
+            <a:gs pos="50000">
+              <a:schemeClr val="phClr">
+                <a:lumMod val="105000"/>
+                <a:satMod val="103000"/>
+                <a:tint val="73000"/>
+              </a:schemeClr>
+            </a:gs>
+            <a:gs pos="100000">
+              <a:schemeClr val="phClr">
+                <a:lumMod val="105000"/>
+                <a:satMod val="109000"/>
+                <a:tint val="81000"/>
+              </a:schemeClr>
+            </a:gs>
+          </a:gsLst>
+          <a:lin ang="5400000" scaled="0"/>
+        </a:gradFill>
+        <a:gradFill rotWithShape="1">
+          <a:gsLst>
+            <a:gs pos="0">
+              <a:schemeClr val="phClr">
+                <a:satMod val="103000"/>
+                <a:lumMod val="102000"/>
+                <a:tint val="94000"/>
+              </a:schemeClr>
+            </a:gs>
+            <a:gs pos="50000">
+              <a:schemeClr val="phClr">
+                <a:satMod val="110000"/>
+                <a:lumMod val="100000"/>
+                <a:shade val="100000"/>
+              </a:schemeClr>
+            </a:gs>
+            <a:gs pos="100000">
+              <a:schemeClr val="phClr">
+                <a:lumMod val="99000"/>
+                <a:satMod val="120000"/>
+                <a:shade val="78000"/>
+              </a:schemeClr>
+            </a:gs>
+          </a:gsLst>
+          <a:lin ang="5400000" scaled="0"/>
+        </a:gradFill>
+      </a:fillStyleLst>
+      <a:lnStyleLst>
+        <a:ln w="12700" cap="flat" cmpd="sng" algn="ctr">
+          <a:solidFill>
+            <a:schemeClr val="phClr"/>
+          </a:solidFill>
+          <a:prstDash val="solid"/>
+          <a:miter lim="800000"/>
+        </a:ln>
+        <a:ln w="19050" cap="flat" cmpd="sng" algn="ctr">
+          <a:solidFill>
+            <a:schemeClr val="phClr"/>
+          </a:solidFill>
+          <a:prstDash val="solid"/>
+          <a:miter lim="800000"/>
+        </a:ln>
+        <a:ln w="25400" cap="flat" cmpd="sng" algn="ctr">
+          <a:solidFill>
+            <a:schemeClr val="phClr"/>
+          </a:solidFill>
+          <a:prstDash val="solid"/>
+          <a:miter lim="800000"/>
+        </a:ln>
+      </a:lnStyleLst>
+      <a:effectStyleLst>
+        <a:effectStyle>
+          <a:effectLst/>
+        </a:effectStyle>
+        <a:effectStyle>
+          <a:effectLst/>
+        </a:effectStyle>
+        <a:effectStyle>
+          <a:effectLst>
+            <a:outerShdw blurRad="57150" dist="19050" dir="5400000" algn="ctr" rotWithShape="0">
+              <a:srgbClr val="000000">
+                <a:alpha val="63000"/>
+              </a:srgbClr>
+            </a:outerShdw>
+          </a:effectLst>
+        </a:effectStyle>
+      </a:effectStyleLst>
+      <a:bgFillStyleLst>
+        <a:solidFill>
+          <a:schemeClr val="phClr"/>
+        </a:solidFill>
+        <a:solidFill>
+          <a:schemeClr val="phClr">
+            <a:tint val="95000"/>
+            <a:satMod val="170000"/>
+          </a:schemeClr>
+        </a:solidFill>
+        <a:gradFill rotWithShape="1">
+          <a:gsLst>
+            <a:gs pos="0">
+              <a:schemeClr val="phClr">
+                <a:tint val="93000"/>
+                <a:satMod val="150000"/>
+                <a:shade val="98000"/>
+                <a:lumMod val="102000"/>
+              </a:schemeClr>
+            </a:gs>
+            <a:gs pos="50000">
+              <a:schemeClr val="phClr">
+                <a:tint val="98000"/>
+                <a:satMod val="130000"/>
+                <a:shade val="90000"/>
+                <a:lumMod val="103000"/>
+              </a:schemeClr>
+            </a:gs>
+            <a:gs pos="100000">
+              <a:schemeClr val="phClr">
+                <a:shade val="63000"/>
+                <a:satMod val="120000"/>
+              </a:schemeClr>
+            </a:gs>
+          </a:gsLst>
+          <a:lin ang="5400000" scaled="0"/>
+        </a:gradFill>
+      </a:bgFillStyleLst>
+    </a:fmtScheme>
+  </a:themeElements>
+  <a:objectDefaults>
+    <a:lnDef>
+      <a:spPr/>
+      <a:bodyPr/>
+      <a:lstStyle/>
+      <a:style>
+        <a:lnRef idx="2">
+          <a:schemeClr val="accent1"/>
+        </a:lnRef>
+        <a:fillRef idx="0">
+          <a:schemeClr val="accent1"/>
+        </a:fillRef>
+        <a:effectRef idx="1">
+          <a:schemeClr val="accent1"/>
+        </a:effectRef>
+        <a:fontRef idx="minor">
+          <a:schemeClr val="tx1"/>
+        </a:fontRef>
+      </a:style>
+    </a:lnDef>
+  </a:objectDefaults>
+  <a:extraClrSchemeLst/>
+  <a:extLst>
+    <a:ext uri="{05A4C25C-085E-4340-85A3-A5531E510DB2}">
+      <thm15:themeFamily xmlns:thm15="http://schemas.microsoft.com/office/thememl/2012/main" name="Office Theme" id="{2E142A2C-CD16-42D6-873A-C26D2A0506FA}" vid="{1BDDFF52-6CD6-40A5-AB3C-68EB2F1E4D0A}"/>
+    </a:ext>
+  </a:extLst>
+</a:theme>
 </file>
</xml_diff>